<commit_message>
Shto versionin nëntë-minutësh të prezantimit
Të njëjtat sllajde me tekst folës më të gjatë; fleta mban seancën nga agjenda dhe kohën e të dy versioneve.
</commit_message>
<xml_diff>
--- a/docs/konferenca/UBT2026_Florent_Latifi.pptx
+++ b/docs/konferenca/UBT2026_Florent_Latifi.pptx
@@ -913,6 +913,7 @@
           <a:lstStyle/>
           <a:p>
             <a:r>
+              <a:rPr i="0"/>
               <a:t>Good morning, everyone. My name is Florent Latifi, and this work comes from my bachelor thesis at UBT, supervised by Altina Salihu. In the next ten minutes I will show how we can detect code smells in Java automatically, how accurate that detection really is, and how far we can go in fixing them.</a:t>
             </a:r>
           </a:p>
@@ -1473,6 +1474,7 @@
           <a:lstStyle/>
           <a:p>
             <a:r>
+              <a:rPr i="0"/>
               <a:t>Every developer knows the class that nobody wants to touch. The program works, but every change takes longer than it should. These design problems are called code smells. They are not bugs, but they make maintenance expensive. Most tools find them with fixed thresholds. For example, if a method is longer than a certain number of lines, it is a Long Method. But these numbers were calibrated on other code, and most tools only point at the problem. They do not fix it. So we asked three questions. First, how accurate are the published detection rules? Second, can machine learning do better with the same metrics? And third, can we fix smells automatically without breaking the code?</a:t>
             </a:r>
           </a:p>
@@ -1543,7 +1545,12 @@
           <a:lstStyle/>
           <a:p>
             <a:r>
-              <a:t>To answer them, I built a tool called JavaSmell. It reads Java code and measures 26 metrics for every class and method. On top of these metrics there are three approaches. A uses 8 detection strategies from the literature, such as Lanza and Marinescu and Fowler. B trains machine learning classifiers on the same metrics. And C is a refactoring engine. It rewrites code only when it can prove its preconditions from the syntax tree, and then it checks the result with the Java compiler. On the right you can see the web interface. It also has a plain-language mode for people without a technical background.</a:t>
+              <a:rPr i="0"/>
+              <a:t>To answer them, I built a tool called JavaSmell. It reads Java code and measures 26 metrics for every class and method. On top of these metrics there are three approaches. A uses 8 detection strategies from the literature, such as Lanza and Marinescu and Fowler. B trains machine learning classifiers on the same metrics. And C is a refactoring engine. It rewrites code only when it can prove its preconditions from the syntax tree, and then it checks the result with the Java compiler.</a:t>
+            </a:r>
+            <a:r>
+              <a:rPr i="0"/>
+              <a:t> On the right you can see the web interface. It also has a plain-language mode for people without a technical background.</a:t>
             </a:r>
           </a:p>
         </p:txBody>
@@ -1613,7 +1620,12 @@
           <a:lstStyle/>
           <a:p>
             <a:r>
-              <a:t>For a fair test, we need labels from people. We used MLCQ, a public dataset where professional developers reviewed real open-source Java code. After matching the samples to our tool, we have 9,046 labeled samples from 512 repositories, for four smells. One important detail is how we split the data. Code from the same project looks very similar, so we grouped the data by repository: a model is never tested on a project it learned from. And we report the Matthews correlation coefficient, MCC. Most samples are clean, so simple accuracy would look very good even for a detector that never fires.</a:t>
+              <a:rPr i="0"/>
+              <a:t>For a fair test, we need labels from people. We used MLCQ, a public dataset where professional developers reviewed real open-source Java code. After matching the samples to our tool, we have 9,046 labeled samples from 512 repositories, for four smells.</a:t>
+            </a:r>
+            <a:r>
+              <a:rPr i="0"/>
+              <a:t> One important detail is how we split the data. Code from the same project looks very similar, so we grouped the data by repository: a model is never tested on a project it learned from. And we report the Matthews correlation coefficient, MCC. Most samples are clean, so simple accuracy would look very good even for a detector that never fires.</a:t>
             </a:r>
           </a:p>
         </p:txBody>
@@ -1683,6 +1695,7 @@
           <a:lstStyle/>
           <a:p>
             <a:r>
+              <a:rPr i="0"/>
               <a:t>Here are the main results. The gray bars are the published rules, and the blue bars are the best machine learning model for each smell. The rules are often correct when they fire, but they catch only 17 to 47 percent of the smells that developers marked. The models are better on all four smells, with MCC from 0.32 to 0.72. We also computed 95 percent confidence intervals by resampling repositories. The improvement is clearly above zero for Blob, Data Class and Long Method. For Feature Envy, the difference could be chance.</a:t>
             </a:r>
           </a:p>
@@ -1753,7 +1766,12 @@
           <a:lstStyle/>
           <a:p>
             <a:r>
-              <a:t>Why is Feature Envy so hard? We measured how much the human reviewers agree with each other. For Blob, Data Class and Long Method, two reviewers agree only moderately. For Feature Envy, they agree no better than chance. So the problem is not only the algorithm. It is the definition of the smell itself. If experts do not agree on what a smell is, no detector can learn it well. For me, this is the main lesson of the detection part.</a:t>
+              <a:rPr i="0"/>
+              <a:t>Why is Feature Envy so hard? We measured how much the human reviewers agree with each other. For Blob, Data Class and Long Method, two reviewers agree only moderately. For Feature Envy, they agree no better than chance.</a:t>
+            </a:r>
+            <a:r>
+              <a:rPr i="0"/>
+              <a:t> So the problem is not only the algorithm. It is the definition of the smell itself. If experts do not agree on what a smell is, no detector can learn it well. For me, this is the main lesson of the detection part.</a:t>
             </a:r>
           </a:p>
         </p:txBody>
@@ -1823,7 +1841,12 @@
           <a:lstStyle/>
           <a:p>
             <a:r>
-              <a:t>Now the refactoring engine. It supports three transformations: Extract Method, Replace Nested Conditional with Guard Clauses, and Introduce Parameter Object. On the whole corpus it found 15,800 sites and rewrote 3,532 of them, which is 22 percent. The rest were refused, each with a reason. For us, refusing is a correct result, not a failure. After rewriting, the smell disappeared in 65 percent of the cases. Only 1.6 percent of the rewrites introduced a new type of compilation error, and those never reach the code, because the tool only writes verified rewrites. I also read 60 rewrites by hand: after reweighting, about 63 percent would be acceptable to a developer.</a:t>
+              <a:rPr i="0"/>
+              <a:t>Now the refactoring engine. It supports three transformations: Extract Method, Replace Nested Conditional with Guard Clauses, and Introduce Parameter Object. On the whole corpus it found 15,800 sites and rewrote 3,532 of them, which is 22 percent. The rest were refused, each with a reason.</a:t>
+            </a:r>
+            <a:r>
+              <a:rPr i="0"/>
+              <a:t> For us, refusing is a correct result, not a failure. After rewriting, the smell disappeared in 65 percent of the cases. Only 1.6 percent of the rewrites introduced a new type of compilation error, and those never reach the code, because the tool only writes verified rewrites. I also read 60 rewrites by hand: after reweighting, about 63 percent would be acceptable to a developer.</a:t>
             </a:r>
           </a:p>
         </p:txBody>
@@ -1893,7 +1916,12 @@
           <a:lstStyle/>
           <a:p>
             <a:r>
-              <a:t>Here is one real example from Apache Geode. Before, the whole method is wrapped in one if statement, so everything is nested deeply. After the rewrite, the condition becomes a guard clause with an early return, and the rest of the method moves one level up. The rewrite passed the compiler check, and in my review it was acceptable as it is.</a:t>
+              <a:rPr i="0"/>
+              <a:t>Here is one real example from Apache Geode. Before, the whole method is wrapped in one if statement, so everything is nested deeply. After the rewrite, the condition becomes a guard clause with an early return, and the rest of the method moves one level up.</a:t>
+            </a:r>
+            <a:r>
+              <a:rPr i="0"/>
+              <a:t> The rewrite passed the compiler check, and in my review it was acceptable as it is.</a:t>
             </a:r>
           </a:p>
         </p:txBody>
@@ -1963,7 +1991,12 @@
           <a:lstStyle/>
           <a:p>
             <a:r>
-              <a:t>To be honest about the limits: compiling is not the same as behaving the same. We did not run the projects' test suites, so behavior preservation is future work. We also used one dataset, four smells, and only Java. To summarize: learned boundaries beat fixed thresholds. Safe automatic refactoring is possible, but narrow, and it should be reviewed by a developer. The tool is open source, and every number in this talk can be regenerated with a script. Thank you. I am happy to take your questions.</a:t>
+              <a:rPr i="0"/>
+              <a:t>To be honest about the limits: compiling is not the same as behaving the same. We did not run the projects' test suites, so behavior preservation is future work. We also used one dataset, four smells, and only Java.</a:t>
+            </a:r>
+            <a:r>
+              <a:rPr i="0"/>
+              <a:t> To summarize: learned boundaries beat fixed thresholds. Safe automatic refactoring is possible, but narrow, and it should be reviewed by a developer. The tool is open source, and every number in this talk can be regenerated with a script. Thank you. I am happy to take your questions.</a:t>
             </a:r>
           </a:p>
         </p:txBody>
@@ -5098,7 +5131,7 @@
               </a:defRPr>
             </a:pPr>
             <a:r>
-              <a:t>15th UBT International Conference  ·  IC-CSCE 2026</a:t>
+              <a:t>15th UBT Annual International Conference on Computer Science and Engineering  ·  2026</a:t>
             </a:r>
           </a:p>
         </p:txBody>

</xml_diff>

<commit_message>
Thjeshto tekstin folës dhe shto librin e punimit
Tekst me fjali të shkurtra, 40 pyetje në katër nivele, dhe Punimi_nga_e_para.docx në vend të dokumentit të njohurive.
</commit_message>
<xml_diff>
--- a/docs/konferenca/UBT2026_Florent_Latifi.pptx
+++ b/docs/konferenca/UBT2026_Florent_Latifi.pptx
@@ -951,11 +951,11 @@
             </a:r>
             <a:r>
               <a:rPr i="0"/>
-              <a:t> My name is Florent Latifi, and this work comes from my bachelor thesis at UBT, supervised by Altina Salihu.</a:t>
+              <a:t> My name is Florent Latifi. This is my bachelor thesis at UBT, with my supervisor Altina Salihu.</a:t>
             </a:r>
             <a:r>
               <a:rPr i="0"/>
-              <a:t> In the next ten minutes I will show how we can detect code smells in Java automatically, how accurate that detection really is, and how far we can go in fixing them.</a:t>
+              <a:t> In the next minutes I will show three things: how a tool can find design problems in Java code, how accurate it is, and whether it can also fix them.</a:t>
             </a:r>
           </a:p>
         </p:txBody>
@@ -1026,35 +1026,39 @@
           <a:p>
             <a:r>
               <a:rPr i="0"/>
-              <a:t>To be honest about the limits: compiling is not the same as behaving the same.</a:t>
+              <a:t>To be honest about the limits: code that compiles does not always behave the same.</a:t>
             </a:r>
             <a:r>
               <a:rPr i="0"/>
-              <a:t> We did not run the projects' test suites, so behavior preservation is future work.</a:t>
+              <a:t> I could not run the projects' own tests, so checking the behavior is future work.</a:t>
             </a:r>
             <a:r>
               <a:rPr i="0"/>
-              <a:t> We also used one dataset, four smells, and only Java.</a:t>
+              <a:t> Also: one dataset, four smells, and only Java.</a:t>
             </a:r>
             <a:r>
               <a:rPr i="0"/>
-              <a:t> To summarize: learned boundaries beat fixed thresholds.</a:t>
+              <a:t> So, the three answers.</a:t>
             </a:r>
             <a:r>
               <a:rPr i="0"/>
-              <a:t> Safe automatic refactoring is possible, but narrow, and it should be reviewed by a developer.</a:t>
+              <a:t> One: the published rules are precise, but they miss most smells.</a:t>
             </a:r>
             <a:r>
               <a:rPr i="0"/>
-              <a:t> The tool is open source, and every number in this talk can be regenerated with a script.</a:t>
+              <a:t> Two: machine learning on the same numbers does better.</a:t>
             </a:r>
             <a:r>
               <a:rPr i="0"/>
-              <a:t> Thank you.</a:t>
+              <a:t> Three: automatic fixing is possible and safe, but only for a small part of the code.</a:t>
             </a:r>
             <a:r>
               <a:rPr i="0"/>
-              <a:t> I am happy to take your questions.</a:t>
+              <a:t> Everything is open source, and every number here can be recreated with a script.</a:t>
+            </a:r>
+            <a:r>
+              <a:rPr i="0"/>
+              <a:t> Thank you. I am happy to answer your questions.</a:t>
             </a:r>
           </a:p>
         </p:txBody>
@@ -1619,47 +1623,39 @@
             </a:r>
             <a:r>
               <a:rPr i="0"/>
-              <a:t> The program works, but every change takes longer than it should.</a:t>
+              <a:t> The program works, but every small change takes too long.</a:t>
             </a:r>
             <a:r>
               <a:rPr i="0"/>
-              <a:t> These design problems are called code smells.</a:t>
+              <a:t> We call these design problems code smells.</a:t>
             </a:r>
             <a:r>
               <a:rPr i="0"/>
-              <a:t> They are not bugs, but they make maintenance expensive.</a:t>
+              <a:t> They are not bugs. They make the code expensive to change.</a:t>
             </a:r>
             <a:r>
               <a:rPr i="0"/>
-              <a:t> Most tools find them with fixed thresholds.</a:t>
+              <a:t> Most tools use fixed numbers: if a method has more than 30 lines, it is a Long Method.</a:t>
             </a:r>
             <a:r>
               <a:rPr i="0"/>
-              <a:t> For example, if a method is longer than a certain number of lines, it is a Long Method.</a:t>
+              <a:t> But these numbers come from other projects, and the tools do not fix anything.</a:t>
             </a:r>
             <a:r>
               <a:rPr i="0"/>
-              <a:t> But these numbers were calibrated on other code, and most tools only point at the problem.</a:t>
+              <a:t> So I asked three questions.</a:t>
             </a:r>
             <a:r>
               <a:rPr i="0"/>
-              <a:t> They do not fix it.</a:t>
+              <a:t> One: how accurate are the published rules?</a:t>
             </a:r>
             <a:r>
               <a:rPr i="0"/>
-              <a:t> So we asked three questions.</a:t>
+              <a:t> Two: can machine learning do better?</a:t>
             </a:r>
             <a:r>
               <a:rPr i="0"/>
-              <a:t> First, how accurate are the published detection rules?</a:t>
-            </a:r>
-            <a:r>
-              <a:rPr i="0"/>
-              <a:t> Second, can machine learning do better with the same metrics?</a:t>
-            </a:r>
-            <a:r>
-              <a:rPr i="0"/>
-              <a:t> And third, can we fix smells automatically without breaking the code?</a:t>
+              <a:t> Three: can a tool fix these smells automatically, without breaking the code?</a:t>
             </a:r>
           </a:p>
         </p:txBody>
@@ -1730,19 +1726,23 @@
           <a:p>
             <a:r>
               <a:rPr i="0"/>
-              <a:t>This study looks at four of them.</a:t>
+              <a:t>In this study I look at four smells.</a:t>
             </a:r>
             <a:r>
               <a:rPr i="0"/>
-              <a:t> Blob is a class that does too much.</a:t>
+              <a:t> A Blob is a class that does too much.</a:t>
             </a:r>
             <a:r>
               <a:rPr i="0"/>
-              <a:t> Data Class only holds data and has almost no behavior.</a:t>
+              <a:t> A Data Class only holds data and does almost nothing with it.</a:t>
             </a:r>
             <a:r>
               <a:rPr i="0"/>
-              <a:t> Long Method is a method that has grown too long, and Feature Envy is a method that uses another class more than its own.</a:t>
+              <a:t> A Long Method is a method that has grown too long.</a:t>
+            </a:r>
+            <a:r>
+              <a:rPr i="0"/>
+              <a:t> And Feature Envy is a method that works more with another class than with its own.</a:t>
             </a:r>
           </a:p>
         </p:txBody>
@@ -1813,39 +1813,31 @@
           <a:p>
             <a:r>
               <a:rPr i="0"/>
-              <a:t>To answer these questions, I built a tool called JavaSmell.</a:t>
+              <a:t>To answer the three questions, I built a tool called JavaSmell.</a:t>
             </a:r>
             <a:r>
               <a:rPr i="0"/>
-              <a:t> It reads Java code and measures 26 metrics for every class and method.</a:t>
+              <a:t> It reads Java code and measures 26 numbers for every class and method, like the number of lines or how complex the code is.</a:t>
             </a:r>
             <a:r>
               <a:rPr i="0"/>
-              <a:t> On top of these metrics there are three approaches.</a:t>
+              <a:t> Part A uses 8 rules from well-known books and papers.</a:t>
             </a:r>
             <a:r>
               <a:rPr i="0"/>
-              <a:t> A uses 8 detection strategies from the literature, such as Lanza and Marinescu and Fowler.</a:t>
+              <a:t> Part B uses machine learning on the same numbers.</a:t>
             </a:r>
             <a:r>
               <a:rPr i="0"/>
-              <a:t> B trains machine learning classifiers on the same metrics.</a:t>
+              <a:t> Part C fixes the code, but only when it can prove that the change is safe.</a:t>
             </a:r>
             <a:r>
               <a:rPr i="0"/>
-              <a:t> And C is a refactoring engine.</a:t>
+              <a:t> Then the Java compiler checks the result.</a:t>
             </a:r>
             <a:r>
               <a:rPr i="0"/>
-              <a:t> It rewrites code only when it can prove its preconditions from the syntax tree, and then it checks the result with the Java compiler.</a:t>
-            </a:r>
-            <a:r>
-              <a:rPr i="0"/>
-              <a:t> On the right you can see the web interface.</a:t>
-            </a:r>
-            <a:r>
-              <a:rPr i="0"/>
-              <a:t> It also has a plain-language mode for people without a technical background.</a:t>
+              <a:t> On the right you see the web interface, in plain Albanian, for people who are not experts.</a:t>
             </a:r>
           </a:p>
         </p:txBody>
@@ -1916,31 +1908,27 @@
           <a:p>
             <a:r>
               <a:rPr i="0"/>
-              <a:t>For a fair test, we need labels from people.</a:t>
+              <a:t>To test the tool fairly, I need answers from real people.</a:t>
             </a:r>
             <a:r>
               <a:rPr i="0"/>
-              <a:t> We used MLCQ, a public dataset where professional developers reviewed real open-source Java code.</a:t>
+              <a:t> I used MLCQ, a public dataset where professional developers judged real Java code.</a:t>
             </a:r>
             <a:r>
               <a:rPr i="0"/>
-              <a:t> After matching the samples to our tool, we have 9,046 labeled samples from 512 repositories, for four smells.</a:t>
+              <a:t> In total I have 9,046 pieces of code from 512 open-source projects.</a:t>
             </a:r>
             <a:r>
               <a:rPr i="0"/>
-              <a:t> One important detail is how we split the data.</a:t>
+              <a:t> A model is never tested on a project it has already seen: it learns from four groups of projects and is tested on the fifth.</a:t>
             </a:r>
             <a:r>
               <a:rPr i="0"/>
-              <a:t> Code from the same project looks very similar, so we grouped the data by repository: a model is never tested on a project it learned from.</a:t>
+              <a:t> To score the results I use MCC, not simple accuracy.</a:t>
             </a:r>
             <a:r>
               <a:rPr i="0"/>
-              <a:t> And we report the Matthews correlation coefficient, MCC.</a:t>
-            </a:r>
-            <a:r>
-              <a:rPr i="0"/>
-              <a:t> Most samples are clean, so simple accuracy would look very good even for a detector that never fires.</a:t>
+              <a:t> On Feature Envy, a detector that always says “clean” is 93 percent accurate, but it is useless. Its MCC is zero.</a:t>
             </a:r>
           </a:p>
         </p:txBody>
@@ -2015,31 +2003,27 @@
             </a:r>
             <a:r>
               <a:rPr i="0"/>
-              <a:t> The gray bars are the published rules, and the blue bars are the best machine learning model for each smell.</a:t>
+              <a:t> Gray is the published rules, blue is machine learning.</a:t>
             </a:r>
             <a:r>
               <a:rPr i="0"/>
-              <a:t> The rules are often correct when they fire, but they catch only 17 to 47 percent of the smells that developers marked.</a:t>
+              <a:t> Higher is better: zero means guessing, one means perfect.</a:t>
             </a:r>
             <a:r>
               <a:rPr i="0"/>
-              <a:t> The models are better on all four smells, with MCC from 0.32 to 0.72.</a:t>
+              <a:t> The rules are usually right when they raise an alarm, but out of every 100 real smells, they find only 17 to 47.</a:t>
             </a:r>
             <a:r>
               <a:rPr i="0"/>
-              <a:t> Out of every 100 smells, they find 30 to 83; the price is usually more false alarms.</a:t>
+              <a:t> Machine learning is better on all four smells. It finds 30 to 83 out of 100, but usually with more false alarms.</a:t>
             </a:r>
             <a:r>
               <a:rPr i="0"/>
-              <a:t> We also computed 95 percent confidence intervals by resampling repositories.</a:t>
+              <a:t> For Blob, Data Class and Long Method, the improvement is real, not luck.</a:t>
             </a:r>
             <a:r>
               <a:rPr i="0"/>
-              <a:t> The improvement is clearly above zero for Blob, Data Class and Long Method.</a:t>
-            </a:r>
-            <a:r>
-              <a:rPr i="0"/>
-              <a:t> For Feature Envy, the difference could be chance.</a:t>
+              <a:t> For Feature Envy, it could be luck.</a:t>
             </a:r>
           </a:p>
         </p:txBody>
@@ -2114,15 +2098,15 @@
             </a:r>
             <a:r>
               <a:rPr i="0"/>
-              <a:t> We measured how much the human reviewers agree with each other.</a:t>
+              <a:t> I looked at code that two developers judged, and checked how often they agree.</a:t>
             </a:r>
             <a:r>
               <a:rPr i="0"/>
-              <a:t> For Blob, Data Class and Long Method, two reviewers agree only moderately.</a:t>
+              <a:t> For Blob, Data Class and Long Method, they agree only partly.</a:t>
             </a:r>
             <a:r>
               <a:rPr i="0"/>
-              <a:t> For Feature Envy, they agree no better than chance.</a:t>
+              <a:t> For Feature Envy, they agree no more than a coin flip.</a:t>
             </a:r>
             <a:r>
               <a:rPr i="0"/>
@@ -2130,15 +2114,11 @@
             </a:r>
             <a:r>
               <a:rPr i="0"/>
-              <a:t> It is the definition of the smell itself.</a:t>
+              <a:t> If experts do not agree on what a smell is, no tool can learn it well.</a:t>
             </a:r>
             <a:r>
               <a:rPr i="0"/>
-              <a:t> If experts do not agree on what a smell is, no detector can learn it well.</a:t>
-            </a:r>
-            <a:r>
-              <a:rPr i="0"/>
-              <a:t> For me, this is the main lesson of the detection part.</a:t>
+              <a:t> For me, this is the most important lesson of the first part.</a:t>
             </a:r>
           </a:p>
         </p:txBody>
@@ -2209,35 +2189,39 @@
           <a:p>
             <a:r>
               <a:rPr i="0"/>
-              <a:t>Now the refactoring engine.</a:t>
+              <a:t>Now the third question: can we fix smells automatically?</a:t>
             </a:r>
             <a:r>
               <a:rPr i="0"/>
-              <a:t> It supports three transformations: Extract Method, Replace Nested Conditional with Guard Clauses, and Introduce Parameter Object.</a:t>
+              <a:t> The tool knows three fixes: split a long method, turn a big if into an early exit, and group many parameters into one object.</a:t>
             </a:r>
             <a:r>
               <a:rPr i="0"/>
-              <a:t> On the whole corpus it found 15,800 sites and rewrote 3,532 of them, which is 22 percent.</a:t>
+              <a:t> In all the projects, it found 15,800 places where a fix could apply.</a:t>
             </a:r>
             <a:r>
               <a:rPr i="0"/>
-              <a:t> The rest were refused, each with a reason.</a:t>
+              <a:t> It changed 3,532 of them, about 22 percent.</a:t>
             </a:r>
             <a:r>
               <a:rPr i="0"/>
-              <a:t> For us, refusing is a correct result, not a failure.</a:t>
+              <a:t> It refused the rest, because it could not prove the change was safe, and it always says why.</a:t>
             </a:r>
             <a:r>
               <a:rPr i="0"/>
-              <a:t> After rewriting, the smell disappeared in 65 percent of the cases.</a:t>
+              <a:t> For me, a refusal is a good result, not a failure.</a:t>
             </a:r>
             <a:r>
               <a:rPr i="0"/>
-              <a:t> Only 1.6 percent of the rewrites introduced a new type of compilation error, and those never reach the code, because the tool only writes verified rewrites.</a:t>
+              <a:t> After a change, the smell disappeared in 65 percent of the cases.</a:t>
             </a:r>
             <a:r>
               <a:rPr i="0"/>
-              <a:t> I also read 60 rewrites by hand: after reweighting, about 63 percent would be acceptable to a developer.</a:t>
+              <a:t> Only 1.6 percent of the changes added a new compile error, and those are never written to the code.</a:t>
+            </a:r>
+            <a:r>
+              <a:rPr i="0"/>
+              <a:t> By checking 60 changes by hand, I estimate that about 63 percent would be acceptable to a developer.</a:t>
             </a:r>
           </a:p>
         </p:txBody>
@@ -2308,19 +2292,19 @@
           <a:p>
             <a:r>
               <a:rPr i="0"/>
-              <a:t>Here is one real example from Apache Geode.</a:t>
+              <a:t>Here is one real example, from the Apache Geode project.</a:t>
             </a:r>
             <a:r>
               <a:rPr i="0"/>
-              <a:t> Before, the whole method is wrapped in one if statement, so everything is nested deeply.</a:t>
+              <a:t> Before: the whole method is inside one big if, so all the code is pushed to the right.</a:t>
             </a:r>
             <a:r>
               <a:rPr i="0"/>
-              <a:t> After the rewrite, the condition becomes a guard clause with an early return, and the rest of the method moves one level up.</a:t>
+              <a:t> After: the condition becomes an early return, and the rest of the code moves one level up.</a:t>
             </a:r>
             <a:r>
               <a:rPr i="0"/>
-              <a:t> The rewrite passed the compiler check, and in my review it was acceptable as it is.</a:t>
+              <a:t> The result compiles, and in my review it was acceptable without any change.</a:t>
             </a:r>
           </a:p>
         </p:txBody>

</xml_diff>

<commit_message>
Lidh tekstin folës nga një sllajd te tjetri
</commit_message>
<xml_diff>
--- a/docs/konferenca/UBT2026_Florent_Latifi.pptx
+++ b/docs/konferenca/UBT2026_Florent_Latifi.pptx
@@ -958,7 +958,7 @@
             </a:r>
             <a:r>
               <a:rPr i="0"/>
-              <a:t> In the next minutes I will show three things: how a tool can find design problems in Java code, how accurate it is, and whether it can also fix them.</a:t>
+              <a:t> Today I want to show you three things: how a tool can find design problems in Java code, how accurate it is, and whether it can also fix them.</a:t>
             </a:r>
           </a:p>
         </p:txBody>
@@ -1029,23 +1029,23 @@
           <a:p>
             <a:r>
               <a:rPr i="0"/>
-              <a:t>How do I know a rewrite is correct? I check it in steps.</a:t>
+              <a:t>But a rewrite is only useful if it is correct. So how do I check that? Step by step.</a:t>
             </a:r>
             <a:r>
               <a:rPr i="0"/>
-              <a:t> Before the change, the tool must prove its conditions on the syntax tree, or it refuses.</a:t>
+              <a:t> First, before the change, the tool must prove its conditions on the syntax tree. If it cannot, it refuses.</a:t>
             </a:r>
             <a:r>
               <a:rPr i="0"/>
-              <a:t> After the change, the compiler checks the file: 98 percent pass, and the 58 that fail are never written.</a:t>
+              <a:t> Second, after the change, the compiler checks the file. 98 percent pass, and the 58 that fail are never written.</a:t>
             </a:r>
             <a:r>
               <a:rPr i="0"/>
-              <a:t> Then the smell is measured again: it is gone after 65 percent of the rewrites.</a:t>
+              <a:t> Third, the smell is measured again. It is gone after 65 percent of the rewrites.</a:t>
             </a:r>
             <a:r>
               <a:rPr i="0"/>
-              <a:t> Finally, I read 60 rewrites by hand: about 63 percent were acceptable, and one changed the behavior.</a:t>
+              <a:t> Finally, I read 60 rewrites by hand. About 63 percent were acceptable, and one changed the behavior.</a:t>
             </a:r>
             <a:r>
               <a:rPr i="0"/>
@@ -1120,7 +1120,7 @@
           <a:p>
             <a:r>
               <a:rPr i="0"/>
-              <a:t>Here is one real example, from the Apache Geode project.</a:t>
+              <a:t>Let me show you what one of these rewrites looks like. This is real code, from the Apache Geode project.</a:t>
             </a:r>
             <a:r>
               <a:rPr i="0"/>
@@ -1203,7 +1203,7 @@
           <a:p>
             <a:r>
               <a:rPr i="0"/>
-              <a:t>So, the three answers.</a:t>
+              <a:t>Let me bring it all together. My three questions have three answers.</a:t>
             </a:r>
             <a:r>
               <a:rPr i="0"/>
@@ -1219,11 +1219,11 @@
             </a:r>
             <a:r>
               <a:rPr i="0"/>
-              <a:t> In practice, published thresholds are a starting point, not a final answer, and an automatic fix is a proposal that a developer reviews.</a:t>
+              <a:t> Why does this matter in practice? Published thresholds are a starting point, not a final answer. And an automatic fix is a proposal that a developer still reviews.</a:t>
             </a:r>
             <a:r>
               <a:rPr i="0"/>
-              <a:t> Next, I want to run the projects' own tests, support more fixes, and ask other developers to judge the changes.</a:t>
+              <a:t> And what comes next? I want to run the projects' own tests, support more fixes, and ask other developers to judge the changes.</a:t>
             </a:r>
             <a:r>
               <a:rPr i="0"/>
@@ -1788,7 +1788,11 @@
           <a:p>
             <a:r>
               <a:rPr i="0"/>
-              <a:t>Every developer knows the class that nobody wants to touch.</a:t>
+              <a:t>Let me start with a problem that every developer knows.</a:t>
+            </a:r>
+            <a:r>
+              <a:rPr i="0"/>
+              <a:t> There is always one class that nobody wants to touch.</a:t>
             </a:r>
             <a:r>
               <a:rPr i="0"/>
@@ -1800,15 +1804,15 @@
             </a:r>
             <a:r>
               <a:rPr i="0"/>
-              <a:t> They are not bugs. They make the code expensive to change.</a:t>
+              <a:t> They are not bugs. They just make the code expensive to change.</a:t>
             </a:r>
             <a:r>
               <a:rPr i="0"/>
-              <a:t> Most tools use fixed numbers: if a method has more than 30 lines, it is a Long Method.</a:t>
+              <a:t> Most tools find them with fixed numbers. For example: if a method has more than 30 lines, it is a Long Method.</a:t>
             </a:r>
             <a:r>
               <a:rPr i="0"/>
-              <a:t> But these numbers come from other projects, and the tools do not fix anything.</a:t>
+              <a:t> But these numbers come from other projects, and the tools only point at the problem. They do not fix it.</a:t>
             </a:r>
             <a:r>
               <a:rPr i="0"/>
@@ -1965,19 +1969,19 @@
           <a:p>
             <a:r>
               <a:rPr i="0"/>
-              <a:t>What is new, compared with earlier studies? Three things.</a:t>
+              <a:t>Other researchers have worked on these questions before. So what is new in my work? Three things.</a:t>
             </a:r>
             <a:r>
               <a:rPr i="0"/>
-              <a:t> First, I measure the published rules against professional developers, instead of taking them as correct.</a:t>
+              <a:t> First, earlier studies take the published rules as correct. I measure them against professional developers.</a:t>
             </a:r>
             <a:r>
               <a:rPr i="0"/>
-              <a:t> Second, rules and machine learning are compared on the same samples, with the same score and a split by project.</a:t>
+              <a:t> Second, I compare rules and machine learning in a fair way: on the same samples, with the same score, and with a split by project.</a:t>
             </a:r>
             <a:r>
               <a:rPr i="0"/>
-              <a:t> Third, one tool finds a smell, fixes it, checks it with the compiler, and measures it again.</a:t>
+              <a:t> Third, earlier tools only suggest a fix. Mine finds a smell, fixes it, checks it with the compiler, and measures it again.</a:t>
             </a:r>
           </a:p>
         </p:txBody>
@@ -2048,7 +2052,7 @@
           <a:p>
             <a:r>
               <a:rPr i="0"/>
-              <a:t>In this study I look at four smells.</a:t>
+              <a:t>Before the results, let me show you the four smells I studied.</a:t>
             </a:r>
             <a:r>
               <a:rPr i="0"/>
@@ -2056,7 +2060,7 @@
             </a:r>
             <a:r>
               <a:rPr i="0"/>
-              <a:t> A Data Class only holds data and does almost nothing with it.</a:t>
+              <a:t> A Data Class only holds data, and does almost nothing with it.</a:t>
             </a:r>
             <a:r>
               <a:rPr i="0"/>
@@ -2135,11 +2139,15 @@
           <a:p>
             <a:r>
               <a:rPr i="0"/>
-              <a:t>To answer the three questions, I built a tool called JavaSmell.</a:t>
+              <a:t>To find these smells, and to fix them, I built a tool called JavaSmell.</a:t>
             </a:r>
             <a:r>
               <a:rPr i="0"/>
-              <a:t> It reads Java code and measures 26 numbers for every class and method, like the number of lines or how complex the code is.</a:t>
+              <a:t> First, it reads the Java code and measures 26 numbers for every class and method, like the number of lines, or how complex the code is.</a:t>
+            </a:r>
+            <a:r>
+              <a:rPr i="0"/>
+              <a:t> Then it uses these numbers in three ways.</a:t>
             </a:r>
             <a:r>
               <a:rPr i="0"/>
@@ -2151,11 +2159,11 @@
             </a:r>
             <a:r>
               <a:rPr i="0"/>
-              <a:t> Part C fixes the code, but only when it can prove that the change is safe.</a:t>
+              <a:t> And Part C fixes the code, but only when it can prove that the change is safe.</a:t>
             </a:r>
             <a:r>
               <a:rPr i="0"/>
-              <a:t> On the right you see the web interface, in plain Albanian, for people who are not experts.</a:t>
+              <a:t> On the right you see the web interface. It explains everything in plain Albanian, so you do not need to be an expert.</a:t>
             </a:r>
           </a:p>
         </p:txBody>
@@ -2226,23 +2234,23 @@
           <a:p>
             <a:r>
               <a:rPr i="0"/>
-              <a:t>To test the tool fairly, I need answers from real people.</a:t>
+              <a:t>But a tool is only useful if its answers are right. To check that, I need answers from real people.</a:t>
             </a:r>
             <a:r>
               <a:rPr i="0"/>
-              <a:t> I used MLCQ, a public dataset where professional developers judged real Java code.</a:t>
+              <a:t> So I used MLCQ, a public dataset where professional developers judged real Java code.</a:t>
             </a:r>
             <a:r>
               <a:rPr i="0"/>
-              <a:t> In total I have 9,046 pieces of code from 512 open-source projects.</a:t>
+              <a:t> In total, I have 9,046 pieces of code from 512 open-source projects.</a:t>
             </a:r>
             <a:r>
               <a:rPr i="0"/>
-              <a:t> A model is never tested on a project it has already seen: it learns from four groups of projects and is tested on the fifth.</a:t>
+              <a:t> And the test is fair: a model is never tested on a project it has already seen. It learns from four groups of projects, and it is tested on the fifth.</a:t>
             </a:r>
             <a:r>
               <a:rPr i="0"/>
-              <a:t> To score the results I use MCC, not simple accuracy.</a:t>
+              <a:t> To score the results, I use MCC, not simple accuracy. Here is why.</a:t>
             </a:r>
             <a:r>
               <a:rPr i="0"/>
@@ -2317,7 +2325,7 @@
           <a:p>
             <a:r>
               <a:rPr i="0"/>
-              <a:t>Here are the main results.</a:t>
+              <a:t>So, how good are the rules, and can machine learning do better? Here are the main results.</a:t>
             </a:r>
             <a:r>
               <a:rPr i="0"/>
@@ -2325,11 +2333,11 @@
             </a:r>
             <a:r>
               <a:rPr i="0"/>
-              <a:t> Higher is better: zero means guessing, one means perfect.</a:t>
+              <a:t> Higher is better: zero means guessing, and one means perfect.</a:t>
             </a:r>
             <a:r>
               <a:rPr i="0"/>
-              <a:t> The rules are usually right when they raise an alarm, but out of every 100 real smells, they find only 17 to 47.</a:t>
+              <a:t> The rules are usually right when they raise an alarm. But out of every 100 real smells, they find only 17 to 47.</a:t>
             </a:r>
             <a:r>
               <a:rPr i="0"/>
@@ -2412,11 +2420,11 @@
           <a:p>
             <a:r>
               <a:rPr i="0"/>
-              <a:t>Why is Feature Envy so hard?</a:t>
+              <a:t>You may ask: why is Feature Envy so hard, even for machine learning?</a:t>
             </a:r>
             <a:r>
               <a:rPr i="0"/>
-              <a:t> I looked at code that two developers judged, and checked how often they agree.</a:t>
+              <a:t> To find out, I looked at code that two developers judged, and checked how often they agree.</a:t>
             </a:r>
             <a:r>
               <a:rPr i="0"/>
@@ -2503,11 +2511,11 @@
           <a:p>
             <a:r>
               <a:rPr i="0"/>
-              <a:t>Now the third question: can we fix smells automatically?</a:t>
+              <a:t>So much for finding smells. Now the third question: once we find a smell, can the tool fix it?</a:t>
             </a:r>
             <a:r>
               <a:rPr i="0"/>
-              <a:t> The tool knows three fixes: split a long method, turn a big if into an early exit, and group many parameters into one object.</a:t>
+              <a:t> The tool knows three fixes: it can split a long method, turn a big if into an early exit, or group many parameters into one object.</a:t>
             </a:r>
             <a:r>
               <a:rPr i="0"/>
@@ -2519,15 +2527,15 @@
             </a:r>
             <a:r>
               <a:rPr i="0"/>
-              <a:t> It refused 12,252, because it could not prove the change was safe, and it always says why.</a:t>
+              <a:t> It refused 12,252, because it could not prove that the change was safe. And it always says why.</a:t>
             </a:r>
             <a:r>
               <a:rPr i="0"/>
-              <a:t> The other 16 could not be found again in the file.</a:t>
+              <a:t> The last 16 could not be found again in the file. Together, that makes 15,800.</a:t>
             </a:r>
             <a:r>
               <a:rPr i="0"/>
-              <a:t> For me, a refusal is a good result, not a failure.</a:t>
+              <a:t> For me, a refusal is a good result, not a failure. It is better to refuse than to break someone's code.</a:t>
             </a:r>
           </a:p>
         </p:txBody>
@@ -9906,25 +9914,6 @@
                 <a:latin typeface="Segoe UI Semibold"/>
               </a:rPr>
               <a:t>References</a:t>
-            </a:r>
-          </a:p>
-          <a:p>
-            <a:pPr algn="l">
-              <a:spcBef>
-                <a:spcPts val="600"/>
-              </a:spcBef>
-              <a:spcAft>
-                <a:spcPts val="0"/>
-              </a:spcAft>
-            </a:pPr>
-            <a:r>
-              <a:rPr sz="1600">
-                <a:solidFill>
-                  <a:srgbClr val="4C5560"/>
-                </a:solidFill>
-                <a:latin typeface="Segoe UI"/>
-              </a:rPr>
-              <a:t>Cited on these slides, in IEEE style; the thesis lists all 45 sources</a:t>
             </a:r>
           </a:p>
         </p:txBody>

</xml_diff>